<commit_message>
docs: simplify System Architecture and Technologies slide for college presentation
</commit_message>
<xml_diff>
--- a/docs/CampusPulse_Presentation_Deck.pptx
+++ b/docs/CampusPulse_Presentation_Deck.pptx
@@ -689,7 +689,7 @@
           <a:p>
             <a:r>
               <a:rPr lang="en-US" dirty="0"/>
-              <a:t>For security, we enforce Bcrypt password hashing, NextAuth JWT sessions, and server-side RBAC guards. For deployment, we configured 100% free serverless hosting on Netlify with automated CI/CD and Docker containerization.</a:t>
+              <a:t>For security, students and admins have separate roles so students cannot modify events. Passwords are encrypted safely using Bcrypt. For deployment, the platform is hosted online on Netlify with automated updates from GitHub.</a:t>
             </a:r>
             <a:endParaRPr lang="en-US" dirty="0"/>
           </a:p>
@@ -1041,7 +1041,7 @@
           <a:p>
             <a:r>
               <a:rPr lang="en-US" dirty="0"/>
-              <a:t>CampusPulse is built using the latest industry standards: Next.js 16 App Router with Turbopack, React 19, MongoDB Atlas with connection pooling, NextAuth with Bcrypt encryption, and Capacitor for native Android deployment.</a:t>
+              <a:t>Sir, our project is built using a standard 3-Tier Architecture: Frontend, Backend, and Database. For the frontend, we use React and Next.js with Tailwind CSS for a responsive UI. For the backend, we use Node.js and NextAuth for secure student and admin login. For the database, we use MongoDB Atlas to store all event and user records. Finally, using Capacitor, we also compiled it into an Android app.</a:t>
             </a:r>
             <a:endParaRPr lang="en-US" dirty="0"/>
           </a:p>
@@ -3202,7 +3202,7 @@
           <a:p>
             <a:pPr indent="0" marL="0">
               <a:lnSpc>
-                <a:spcPts val="1500"/>
+                <a:spcPts val="1400"/>
               </a:lnSpc>
               <a:buNone/>
             </a:pPr>
@@ -3215,17 +3215,17 @@
                 <a:ea typeface="Calibri" pitchFamily="34" charset="-122"/>
                 <a:cs typeface="Calibri" pitchFamily="34" charset="-120"/>
               </a:rPr>
-              <a:t>• Role-Based Access Control (RBAC):
+              <a:t>1. Role-Based Access Control (RBAC):
 </a:t>
             </a:r>
             <a:pPr indent="0" marL="0">
               <a:lnSpc>
-                <a:spcPts val="1500"/>
-              </a:lnSpc>
-              <a:buNone/>
-            </a:pPr>
-            <a:r>
-              <a:rPr lang="en-US" sz="1050" dirty="0">
+                <a:spcPts val="1400"/>
+              </a:lnSpc>
+              <a:buNone/>
+            </a:pPr>
+            <a:r>
+              <a:rPr lang="en-US" sz="1000" dirty="0">
                 <a:solidFill>
                   <a:srgbClr val="E2E8F0"/>
                 </a:solidFill>
@@ -3233,12 +3233,13 @@
                 <a:ea typeface="Calibri" pitchFamily="34" charset="-122"/>
                 <a:cs typeface="Calibri" pitchFamily="34" charset="-120"/>
               </a:rPr>
-              <a:t>Server-level guards (requireAdmin(), requireAuth()) strictly protect admin panels, survey creators, and report export endpoints from unauthorized students.
+              <a:t>• Student Role: Can view events, register for sessions, and post Q&amp;A queries.
+• Admin Role: Exclusive access to create/edit events, build surveys, and download reports.
 </a:t>
             </a:r>
             <a:pPr indent="0" marL="0">
               <a:lnSpc>
-                <a:spcPts val="1500"/>
+                <a:spcPts val="1400"/>
               </a:lnSpc>
               <a:buNone/>
             </a:pPr>
@@ -3251,17 +3252,17 @@
                 <a:ea typeface="Calibri" pitchFamily="34" charset="-122"/>
                 <a:cs typeface="Calibri" pitchFamily="34" charset="-120"/>
               </a:rPr>
-              <a:t>• Cryptographic Session Security:
+              <a:t>2. User Authentication &amp; Password Protection:
 </a:t>
             </a:r>
             <a:pPr indent="0" marL="0">
               <a:lnSpc>
-                <a:spcPts val="1500"/>
-              </a:lnSpc>
-              <a:buNone/>
-            </a:pPr>
-            <a:r>
-              <a:rPr lang="en-US" sz="1050" dirty="0">
+                <a:spcPts val="1400"/>
+              </a:lnSpc>
+              <a:buNone/>
+            </a:pPr>
+            <a:r>
+              <a:rPr lang="en-US" sz="1000" dirty="0">
                 <a:solidFill>
                   <a:srgbClr val="E2E8F0"/>
                 </a:solidFill>
@@ -3269,12 +3270,13 @@
                 <a:ea typeface="Calibri" pitchFamily="34" charset="-122"/>
                 <a:cs typeface="Calibri" pitchFamily="34" charset="-120"/>
               </a:rPr>
-              <a:t>Bcrypt password hashing with 10 salt rounds, stateless 30-day JWT sessions, and security headers (nosniff, X-Frame-Options, XSS protection).
+              <a:t>• Secure Login: Powered by NextAuth with encrypted session tokens.
+• Password Hashing: Passwords are encrypted using Bcrypt before saving to database.
 </a:t>
             </a:r>
             <a:pPr indent="0" marL="0">
               <a:lnSpc>
-                <a:spcPts val="1500"/>
+                <a:spcPts val="1400"/>
               </a:lnSpc>
               <a:buNone/>
             </a:pPr>
@@ -3287,17 +3289,17 @@
                 <a:ea typeface="Calibri" pitchFamily="34" charset="-122"/>
                 <a:cs typeface="Calibri" pitchFamily="34" charset="-120"/>
               </a:rPr>
-              <a:t>• 100% Free Serverless Hosting (Netlify):
+              <a:t>3. Online Cloud Hosting (Netlify):
 </a:t>
             </a:r>
             <a:pPr indent="0" marL="0">
               <a:lnSpc>
-                <a:spcPts val="1500"/>
-              </a:lnSpc>
-              <a:buNone/>
-            </a:pPr>
-            <a:r>
-              <a:rPr lang="en-US" sz="1050" dirty="0">
+                <a:spcPts val="1400"/>
+              </a:lnSpc>
+              <a:buNone/>
+            </a:pPr>
+            <a:r>
+              <a:rPr lang="en-US" sz="1000" dirty="0">
                 <a:solidFill>
                   <a:srgbClr val="E2E8F0"/>
                 </a:solidFill>
@@ -3305,12 +3307,13 @@
                 <a:ea typeface="Calibri" pitchFamily="34" charset="-122"/>
                 <a:cs typeface="Calibri" pitchFamily="34" charset="-120"/>
               </a:rPr>
-              <a:t>Fully configured netlify.toml with automated GitHub webhook CI/CD pipeline. Pushing to origin/main triggers instant live deployment.
+              <a:t>• 24/7 Availability: Hosted online on Netlify so students can access from any mobile or PC.
+• Automatic Updates: Pushing code to GitHub automatically redeploys the live platform.
 </a:t>
             </a:r>
             <a:pPr indent="0" marL="0">
               <a:lnSpc>
-                <a:spcPts val="1500"/>
+                <a:spcPts val="1400"/>
               </a:lnSpc>
               <a:buNone/>
             </a:pPr>
@@ -3323,17 +3326,17 @@
                 <a:ea typeface="Calibri" pitchFamily="34" charset="-122"/>
                 <a:cs typeface="Calibri" pitchFamily="34" charset="-120"/>
               </a:rPr>
-              <a:t>• Production Multi-Stage Dockerization:
+              <a:t>4. Deployment Portability (Docker):
 </a:t>
             </a:r>
             <a:pPr indent="0" marL="0">
               <a:lnSpc>
-                <a:spcPts val="1500"/>
-              </a:lnSpc>
-              <a:buNone/>
-            </a:pPr>
-            <a:r>
-              <a:rPr lang="en-US" sz="1050" dirty="0">
+                <a:spcPts val="1400"/>
+              </a:lnSpc>
+              <a:buNone/>
+            </a:pPr>
+            <a:r>
+              <a:rPr lang="en-US" sz="1000" dirty="0">
                 <a:solidFill>
                   <a:srgbClr val="E2E8F0"/>
                 </a:solidFill>
@@ -3341,7 +3344,7 @@
                 <a:ea typeface="Calibri" pitchFamily="34" charset="-122"/>
                 <a:cs typeface="Calibri" pitchFamily="34" charset="-120"/>
               </a:rPr>
-              <a:t>Lightweight Dockerfile (Node 20 Alpine) with non-root user and docker-compose.yml with persistent volume mounting for VPS hosting.</a:t>
+              <a:t>• Container Support: Can also run on local college servers or VPS using Docker.</a:t>
             </a:r>
             <a:endParaRPr lang="en-US" sz="1150" dirty="0"/>
           </a:p>
@@ -3473,7 +3476,7 @@
                 <a:ea typeface="Segoe UI" pitchFamily="34" charset="-122"/>
                 <a:cs typeface="Segoe UI" pitchFamily="34" charset="-120"/>
               </a:rPr>
-              <a:t>[INSERT DEVOPS FLOWCHART]</a:t>
+              <a:t>[INSERT DEPLOYMENT DIAGRAM]</a:t>
             </a:r>
             <a:endParaRPr lang="en-US" sz="1400" dirty="0"/>
           </a:p>
@@ -3512,7 +3515,7 @@
                 <a:ea typeface="Calibri" pitchFamily="34" charset="-122"/>
                 <a:cs typeface="Calibri" pitchFamily="34" charset="-120"/>
               </a:rPr>
-              <a:t>Diagram showing the CI/CD pipeline: Git Commit -&gt; GitHub Push -&gt; Netlify Automatic Webhook Build -&gt; Live Web &amp; Mobile App.</a:t>
+              <a:t>Simple flow: Code on GitHub → Automatic Build → Live Website on Netlify &amp; Android Mobile App.</a:t>
             </a:r>
             <a:endParaRPr lang="en-US" sz="1100" dirty="0"/>
           </a:p>
@@ -5485,7 +5488,7 @@
                 <a:ea typeface="Calibri" pitchFamily="34" charset="-122"/>
                 <a:cs typeface="Calibri" pitchFamily="34" charset="-120"/>
               </a:rPr>
-              <a:t>03 / TECHNICAL FOUNDATIONS</a:t>
+              <a:t>03 / TECHNICAL OVERVIEW</a:t>
             </a:r>
             <a:endParaRPr lang="en-US" sz="1000" dirty="0"/>
           </a:p>
@@ -5524,7 +5527,7 @@
                 <a:ea typeface="Segoe UI" pitchFamily="34" charset="-122"/>
                 <a:cs typeface="Segoe UI" pitchFamily="34" charset="-120"/>
               </a:rPr>
-              <a:t>System Architecture &amp; Technology Stack</a:t>
+              <a:t>System Architecture &amp; Technologies Used</a:t>
             </a:r>
             <a:endParaRPr lang="en-US" sz="2200" dirty="0"/>
           </a:p>
@@ -5655,7 +5658,7 @@
                 <a:ea typeface="Calibri" pitchFamily="34" charset="-122"/>
                 <a:cs typeface="Calibri" pitchFamily="34" charset="-120"/>
               </a:rPr>
-              <a:t>• Frontend Layer:
+              <a:t>1. Frontend (User Interface):
 </a:t>
             </a:r>
             <a:pPr indent="0" marL="0">
@@ -5673,7 +5676,8 @@
                 <a:ea typeface="Calibri" pitchFamily="34" charset="-122"/>
                 <a:cs typeface="Calibri" pitchFamily="34" charset="-120"/>
               </a:rPr>
-              <a:t>Next.js 16.3.3 (Turbopack, App Router), React 19.2.8, Tailwind CSS v4, Framer Motion for smooth micro-animations, Lucide React icons.
+              <a:t>• React.js &amp; Next.js: For building clean, interactive web pages and smooth page navigation.
+• Tailwind CSS: Provides a modern, responsive design that works on both mobile phones and laptops.
 </a:t>
             </a:r>
             <a:pPr indent="0" marL="0">
@@ -5691,7 +5695,7 @@
                 <a:ea typeface="Calibri" pitchFamily="34" charset="-122"/>
                 <a:cs typeface="Calibri" pitchFamily="34" charset="-120"/>
               </a:rPr>
-              <a:t>• Backend &amp; Server Actions:
+              <a:t>2. Backend (Application Logic):
 </a:t>
             </a:r>
             <a:pPr indent="0" marL="0">
@@ -5709,7 +5713,8 @@
                 <a:ea typeface="Calibri" pitchFamily="34" charset="-122"/>
                 <a:cs typeface="Calibri" pitchFamily="34" charset="-120"/>
               </a:rPr>
-              <a:t>Next.js Server Actions (src/actions/) with 50MB body streaming, Edge Route Handlers, role-based middleware guards.
+              <a:t>• Node.js &amp; Next.js: Handles event registrations, form submissions, and user requests.
+• NextAuth: Simple and secure login management for students and college admins.
 </a:t>
             </a:r>
             <a:pPr indent="0" marL="0">
@@ -5727,7 +5732,7 @@
                 <a:ea typeface="Calibri" pitchFamily="34" charset="-122"/>
                 <a:cs typeface="Calibri" pitchFamily="34" charset="-120"/>
               </a:rPr>
-              <a:t>• Database &amp; ORM:
+              <a:t>3. Database (Data Storage):
 </a:t>
             </a:r>
             <a:pPr indent="0" marL="0">
@@ -5745,7 +5750,8 @@
                 <a:ea typeface="Calibri" pitchFamily="34" charset="-122"/>
                 <a:cs typeface="Calibri" pitchFamily="34" charset="-120"/>
               </a:rPr>
-              <a:t>MongoDB Atlas Cloud, Mongoose 9.9.4 with Global Connection Caching Singleton and Google Public DNS (8.8.8.8) SRV resolver.
+              <a:t>• MongoDB Atlas: Cloud NoSQL database that stores user profiles, event details, and survey feedback.
+• Mongoose: Connects our application easily to MongoDB with structured data schemas.
 </a:t>
             </a:r>
             <a:pPr indent="0" marL="0">
@@ -5763,7 +5769,7 @@
                 <a:ea typeface="Calibri" pitchFamily="34" charset="-122"/>
                 <a:cs typeface="Calibri" pitchFamily="34" charset="-120"/>
               </a:rPr>
-              <a:t>• Authentication &amp; Security:
+              <a:t>4. Architecture &amp; Mobile Support:
 </a:t>
             </a:r>
             <a:pPr indent="0" marL="0">
@@ -5781,9 +5787,11 @@
                 <a:ea typeface="Calibri" pitchFamily="34" charset="-122"/>
                 <a:cs typeface="Calibri" pitchFamily="34" charset="-120"/>
               </a:rPr>
-              <a:t>NextAuth.js v4 (Stateless JWT sessions, Bcrypt password hashing with 10 salt rounds, strict student/admin RBAC).
-</a:t>
-            </a:r>
+              <a:t>• 3-Tier Architecture: Presentation Layer (UI) → Application Layer (Server) → Database (MongoDB).</a:t>
+            </a:r>
+            <a:endParaRPr lang="en-US" sz="1150" dirty="0"/>
+          </a:p>
+          <a:p>
             <a:pPr indent="0" marL="0">
               <a:lnSpc>
                 <a:spcPts val="1400"/>
@@ -5791,24 +5799,6 @@
               <a:buNone/>
             </a:pPr>
             <a:r>
-              <a:rPr lang="en-US" sz="1150" b="1" dirty="0">
-                <a:solidFill>
-                  <a:srgbClr val="6366F1"/>
-                </a:solidFill>
-                <a:latin typeface="Calibri" pitchFamily="34" charset="0"/>
-                <a:ea typeface="Calibri" pitchFamily="34" charset="-122"/>
-                <a:cs typeface="Calibri" pitchFamily="34" charset="-120"/>
-              </a:rPr>
-              <a:t>• Mobile &amp; Deployment:
-</a:t>
-            </a:r>
-            <a:pPr indent="0" marL="0">
-              <a:lnSpc>
-                <a:spcPts val="1400"/>
-              </a:lnSpc>
-              <a:buNone/>
-            </a:pPr>
-            <a:r>
               <a:rPr lang="en-US" sz="1000" dirty="0">
                 <a:solidFill>
                   <a:srgbClr val="E2E8F0"/>
@@ -5817,7 +5807,7 @@
                 <a:ea typeface="Calibri" pitchFamily="34" charset="-122"/>
                 <a:cs typeface="Calibri" pitchFamily="34" charset="-120"/>
               </a:rPr>
-              <a:t>Capacitor 8.5 (Native Android APK), Netlify Serverless with automated GitHub webhooks, Multi-stage Docker container.</a:t>
+              <a:t>• Capacitor: Packages the web project into an installable Android App (APK).</a:t>
             </a:r>
             <a:endParaRPr lang="en-US" sz="1150" dirty="0"/>
           </a:p>
@@ -5949,7 +5939,7 @@
                 <a:ea typeface="Segoe UI" pitchFamily="34" charset="-122"/>
                 <a:cs typeface="Segoe UI" pitchFamily="34" charset="-120"/>
               </a:rPr>
-              <a:t>[INSERT ARCHITECTURE DIAGRAM]</a:t>
+              <a:t>[INSERT 3-TIER ARCHITECTURE DIAGRAM]</a:t>
             </a:r>
             <a:endParaRPr lang="en-US" sz="1400" dirty="0"/>
           </a:p>
@@ -5988,7 +5978,7 @@
                 <a:ea typeface="Calibri" pitchFamily="34" charset="-122"/>
                 <a:cs typeface="Calibri" pitchFamily="34" charset="-120"/>
               </a:rPr>
-              <a:t>Three-tier architecture diagram showing Client (Web &amp; Android), Next.js 16 Server Actions / NextAuth, and MongoDB Atlas Persistence layer.</a:t>
+              <a:t>Simple 3-tier diagram: User Interface (Web / Android) → Application Server (Node/Next.js) → Cloud Database (MongoDB Atlas).</a:t>
             </a:r>
             <a:endParaRPr lang="en-US" sz="1100" dirty="0"/>
           </a:p>

</xml_diff>

<commit_message>
docs: replace slide 10 (Android App) and slide 11 (Security/DevOps) with User Workflow (DFD) and System Testing results
</commit_message>
<xml_diff>
--- a/docs/CampusPulse_Presentation_Deck.pptx
+++ b/docs/CampusPulse_Presentation_Deck.pptx
@@ -601,7 +601,7 @@
           <a:p>
             <a:r>
               <a:rPr lang="en-US" dirty="0"/>
-              <a:t>CampusPulse is not just a website; it is packaged as a native Android APK using Capacitor 8.5. We have already compiled CampusPulse.apk which can be installed directly on any student smartphone.</a:t>
+              <a:t>Sir, Slide 10 explains the complete User Workflow and Data Flow. A student logs in, discovers events, and registers with 1 click. During the event, they participate in live Q&amp;A, and post-event they submit feedback. On the coordinator side, all registrations and feedback are tracked in real time.</a:t>
             </a:r>
             <a:endParaRPr lang="en-US" dirty="0"/>
           </a:p>
@@ -689,7 +689,7 @@
           <a:p>
             <a:r>
               <a:rPr lang="en-US" dirty="0"/>
-              <a:t>For security, students and admins have separate roles so students cannot modify events. Passwords are encrypted safely using Bcrypt. For deployment, the platform is hosted online on Netlify with automated updates from GitHub.</a:t>
+              <a:t>In Slide 11, we cover system testing. We conducted functional testing on core modules: verifying that capacity locks prevent overbooking, upvoting cannot be duplicated, unauthorized users cannot access admin pages, and forms validate correctly across mobile and desktop.</a:t>
             </a:r>
             <a:endParaRPr lang="en-US" dirty="0"/>
           </a:p>
@@ -2478,7 +2478,7 @@
                 <a:ea typeface="Calibri" pitchFamily="34" charset="-122"/>
                 <a:cs typeface="Calibri" pitchFamily="34" charset="-120"/>
               </a:rPr>
-              <a:t>09 / CROSS-PLATFORM ENGINEERING</a:t>
+              <a:t>09 / SYSTEM WORKFLOW &amp; DFD</a:t>
             </a:r>
             <a:endParaRPr lang="en-US" sz="1000" dirty="0"/>
           </a:p>
@@ -2517,7 +2517,7 @@
                 <a:ea typeface="Segoe UI" pitchFamily="34" charset="-122"/>
                 <a:cs typeface="Segoe UI" pitchFamily="34" charset="-120"/>
               </a:rPr>
-              <a:t>Native Android Mobile Application (Capacitor 8.5)</a:t>
+              <a:t>User Workflow &amp; Data Flow Diagram (DFD)</a:t>
             </a:r>
             <a:endParaRPr lang="en-US" sz="2200" dirty="0"/>
           </a:p>
@@ -2635,7 +2635,7 @@
           <a:p>
             <a:pPr indent="0" marL="0">
               <a:lnSpc>
-                <a:spcPts val="1500"/>
+                <a:spcPts val="1400"/>
               </a:lnSpc>
               <a:buNone/>
             </a:pPr>
@@ -2648,17 +2648,17 @@
                 <a:ea typeface="Calibri" pitchFamily="34" charset="-122"/>
                 <a:cs typeface="Calibri" pitchFamily="34" charset="-120"/>
               </a:rPr>
-              <a:t>• Hybrid Native Architecture:
+              <a:t>1. Student Discovery &amp; Registration Flow:
 </a:t>
             </a:r>
             <a:pPr indent="0" marL="0">
               <a:lnSpc>
-                <a:spcPts val="1500"/>
-              </a:lnSpc>
-              <a:buNone/>
-            </a:pPr>
-            <a:r>
-              <a:rPr lang="en-US" sz="1050" dirty="0">
+                <a:spcPts val="1400"/>
+              </a:lnSpc>
+              <a:buNone/>
+            </a:pPr>
+            <a:r>
+              <a:rPr lang="en-US" sz="1000" dirty="0">
                 <a:solidFill>
                   <a:srgbClr val="E2E8F0"/>
                 </a:solidFill>
@@ -2666,12 +2666,13 @@
                 <a:ea typeface="Calibri" pitchFamily="34" charset="-122"/>
                 <a:cs typeface="Calibri" pitchFamily="34" charset="-120"/>
               </a:rPr>
-              <a:t>Packaged using Capacitor 8.5 into a full-screen, hardware-accelerated Android WebView with native lifecycle controls.
+              <a:t>• Student browses the event catalog with category filters (Technical/Cultural/Sports).
+• Clicks 'Register for Event' → System atomically reserves the seat &amp; generates a unique Reference ID.
 </a:t>
             </a:r>
             <a:pPr indent="0" marL="0">
               <a:lnSpc>
-                <a:spcPts val="1500"/>
+                <a:spcPts val="1400"/>
               </a:lnSpc>
               <a:buNone/>
             </a:pPr>
@@ -2684,17 +2685,17 @@
                 <a:ea typeface="Calibri" pitchFamily="34" charset="-122"/>
                 <a:cs typeface="Calibri" pitchFamily="34" charset="-120"/>
               </a:rPr>
-              <a:t>• Standalone Production Binary (CampusPulse.apk):
+              <a:t>2. Live In-Session Engagement Flow:
 </a:t>
             </a:r>
             <a:pPr indent="0" marL="0">
               <a:lnSpc>
-                <a:spcPts val="1500"/>
-              </a:lnSpc>
-              <a:buNone/>
-            </a:pPr>
-            <a:r>
-              <a:rPr lang="en-US" sz="1050" dirty="0">
+                <a:spcPts val="1400"/>
+              </a:lnSpc>
+              <a:buNone/>
+            </a:pPr>
+            <a:r>
+              <a:rPr lang="en-US" sz="1000" dirty="0">
                 <a:solidFill>
                   <a:srgbClr val="E2E8F0"/>
                 </a:solidFill>
@@ -2702,12 +2703,13 @@
                 <a:ea typeface="Calibri" pitchFamily="34" charset="-122"/>
                 <a:cs typeface="Calibri" pitchFamily="34" charset="-120"/>
               </a:rPr>
-              <a:t>Pre-compiled APK (Application ID: com.campuspulse.app, Size: ~3.68 MB) ready for direct sideloading and Play Store distribution.
+              <a:t>• During live talks/sessions, attendee opens the live Q&amp;A forum.
+• Submits questions &amp; upvotes trending peer queries in real time without interrupting speakers.
 </a:t>
             </a:r>
             <a:pPr indent="0" marL="0">
               <a:lnSpc>
-                <a:spcPts val="1500"/>
+                <a:spcPts val="1400"/>
               </a:lnSpc>
               <a:buNone/>
             </a:pPr>
@@ -2720,17 +2722,17 @@
                 <a:ea typeface="Calibri" pitchFamily="34" charset="-122"/>
                 <a:cs typeface="Calibri" pitchFamily="34" charset="-120"/>
               </a:rPr>
-              <a:t>• Native Assets &amp; Brand Isolation:
+              <a:t>3. Post-Event Feedback Submission:
 </a:t>
             </a:r>
             <a:pPr indent="0" marL="0">
               <a:lnSpc>
-                <a:spcPts val="1500"/>
-              </a:lnSpc>
-              <a:buNone/>
-            </a:pPr>
-            <a:r>
-              <a:rPr lang="en-US" sz="1050" dirty="0">
+                <a:spcPts val="1400"/>
+              </a:lnSpc>
+              <a:buNone/>
+            </a:pPr>
+            <a:r>
+              <a:rPr lang="en-US" sz="1000" dirty="0">
                 <a:solidFill>
                   <a:srgbClr val="E2E8F0"/>
                 </a:solidFill>
@@ -2738,12 +2740,12 @@
                 <a:ea typeface="Calibri" pitchFamily="34" charset="-122"/>
                 <a:cs typeface="Calibri" pitchFamily="34" charset="-120"/>
               </a:rPr>
-              <a:t>Custom branded splash screens (splash.png) and adaptive launcher icons across all Android DPI buckets (hdpi to xxxhdpi).
+              <a:t>• When the event concludes, attendee completes a dynamic survey form (1-5 star ratings &amp; comments).
 </a:t>
             </a:r>
             <a:pPr indent="0" marL="0">
               <a:lnSpc>
-                <a:spcPts val="1500"/>
+                <a:spcPts val="1400"/>
               </a:lnSpc>
               <a:buNone/>
             </a:pPr>
@@ -2756,17 +2758,17 @@
                 <a:ea typeface="Calibri" pitchFamily="34" charset="-122"/>
                 <a:cs typeface="Calibri" pitchFamily="34" charset="-120"/>
               </a:rPr>
-              <a:t>• Live Sync Cloud Updates:
+              <a:t>4. Admin &amp; Coordinator Management Flow:
 </a:t>
             </a:r>
             <a:pPr indent="0" marL="0">
               <a:lnSpc>
-                <a:spcPts val="1500"/>
-              </a:lnSpc>
-              <a:buNone/>
-            </a:pPr>
-            <a:r>
-              <a:rPr lang="en-US" sz="1050" dirty="0">
+                <a:spcPts val="1400"/>
+              </a:lnSpc>
+              <a:buNone/>
+            </a:pPr>
+            <a:r>
+              <a:rPr lang="en-US" sz="1000" dirty="0">
                 <a:solidFill>
                   <a:srgbClr val="E2E8F0"/>
                 </a:solidFill>
@@ -2774,7 +2776,7 @@
                 <a:ea typeface="Calibri" pitchFamily="34" charset="-122"/>
                 <a:cs typeface="Calibri" pitchFamily="34" charset="-120"/>
               </a:rPr>
-              <a:t>Connects to production remote URL (APP_URL), enabling web updates to reflect instantly on mobile devices without requiring app store updates.</a:t>
+              <a:t>• Admin creates events with capacity limits, monitors registrations, and exports 1-click PDF reports.</a:t>
             </a:r>
             <a:endParaRPr lang="en-US" sz="1150" dirty="0"/>
           </a:p>
@@ -2906,7 +2908,7 @@
                 <a:ea typeface="Segoe UI" pitchFamily="34" charset="-122"/>
                 <a:cs typeface="Segoe UI" pitchFamily="34" charset="-120"/>
               </a:rPr>
-              <a:t>[INSERT SCREENSHOT: Android App / Phone Mockup]</a:t>
+              <a:t>[INSERT DATA FLOW DIAGRAM / DFD]</a:t>
             </a:r>
             <a:endParaRPr lang="en-US" sz="1400" dirty="0"/>
           </a:p>
@@ -2945,7 +2947,7 @@
                 <a:ea typeface="Calibri" pitchFamily="34" charset="-122"/>
                 <a:cs typeface="Calibri" pitchFamily="34" charset="-120"/>
               </a:rPr>
-              <a:t>Photo of CampusPulse running on an Android smartphone screen, showing the mobile navigation drawer and event cards.</a:t>
+              <a:t>Flowchart: User Login → Event Discovery → 1-Click Registration → Live Q&amp;A → Survey Feedback → Admin Report Generation.</a:t>
             </a:r>
             <a:endParaRPr lang="en-US" sz="1100" dirty="0"/>
           </a:p>
@@ -3045,7 +3047,7 @@
                 <a:ea typeface="Calibri" pitchFamily="34" charset="-122"/>
                 <a:cs typeface="Calibri" pitchFamily="34" charset="-120"/>
               </a:rPr>
-              <a:t>10 / DEVOPS &amp; GOVERNANCE</a:t>
+              <a:t>10 / TESTING &amp; VERIFICATION</a:t>
             </a:r>
             <a:endParaRPr lang="en-US" sz="1000" dirty="0"/>
           </a:p>
@@ -3084,7 +3086,7 @@
                 <a:ea typeface="Segoe UI" pitchFamily="34" charset="-122"/>
                 <a:cs typeface="Segoe UI" pitchFamily="34" charset="-120"/>
               </a:rPr>
-              <a:t>Security, RBAC &amp; Multi-Platform DevOps</a:t>
+              <a:t>System Testing &amp; Validation Results</a:t>
             </a:r>
             <a:endParaRPr lang="en-US" sz="2200" dirty="0"/>
           </a:p>
@@ -3215,7 +3217,7 @@
                 <a:ea typeface="Calibri" pitchFamily="34" charset="-122"/>
                 <a:cs typeface="Calibri" pitchFamily="34" charset="-120"/>
               </a:rPr>
-              <a:t>1. Role-Based Access Control (RBAC):
+              <a:t>1. Authentication &amp; Security Testing:
 </a:t>
             </a:r>
             <a:pPr indent="0" marL="0">
@@ -3233,8 +3235,8 @@
                 <a:ea typeface="Calibri" pitchFamily="34" charset="-122"/>
                 <a:cs typeface="Calibri" pitchFamily="34" charset="-120"/>
               </a:rPr>
-              <a:t>• Student Role: Can view events, register for sessions, and post Q&amp;A queries.
-• Admin Role: Exclusive access to create/edit events, build surveys, and download reports.
+              <a:t>• Verified secure student login &amp; password encryption via Bcrypt.
+• Tested Role Guards: Confirmed student accounts cannot access admin routes (/admin).
 </a:t>
             </a:r>
             <a:pPr indent="0" marL="0">
@@ -3252,7 +3254,7 @@
                 <a:ea typeface="Calibri" pitchFamily="34" charset="-122"/>
                 <a:cs typeface="Calibri" pitchFamily="34" charset="-120"/>
               </a:rPr>
-              <a:t>2. User Authentication &amp; Password Protection:
+              <a:t>2. Capacity Lock &amp; RSVP Testing:
 </a:t>
             </a:r>
             <a:pPr indent="0" marL="0">
@@ -3270,8 +3272,8 @@
                 <a:ea typeface="Calibri" pitchFamily="34" charset="-122"/>
                 <a:cs typeface="Calibri" pitchFamily="34" charset="-120"/>
               </a:rPr>
-              <a:t>• Secure Login: Powered by NextAuth with encrypted session tokens.
-• Password Hashing: Passwords are encrypted using Bcrypt before saving to database.
+              <a:t>• Tested event limit: Verified system blocks registrations when maxCapacity is reached ('Event Full').
+• Verified that cancellation immediately restores seat availability for other students.
 </a:t>
             </a:r>
             <a:pPr indent="0" marL="0">
@@ -3289,7 +3291,7 @@
                 <a:ea typeface="Calibri" pitchFamily="34" charset="-122"/>
                 <a:cs typeface="Calibri" pitchFamily="34" charset="-120"/>
               </a:rPr>
-              <a:t>3. Online Cloud Hosting (Netlify):
+              <a:t>3. Live Q&amp;A Deduplication Testing:
 </a:t>
             </a:r>
             <a:pPr indent="0" marL="0">
@@ -3307,8 +3309,7 @@
                 <a:ea typeface="Calibri" pitchFamily="34" charset="-122"/>
                 <a:cs typeface="Calibri" pitchFamily="34" charset="-120"/>
               </a:rPr>
-              <a:t>• 24/7 Availability: Hosted online on Netlify so students can access from any mobile or PC.
-• Automatic Updates: Pushing code to GitHub automatically redeploys the live platform.
+              <a:t>• Tested upvote logic: Confirmed a student cannot double-vote or spam upvotes on the same question.
 </a:t>
             </a:r>
             <a:pPr indent="0" marL="0">
@@ -3326,7 +3327,7 @@
                 <a:ea typeface="Calibri" pitchFamily="34" charset="-122"/>
                 <a:cs typeface="Calibri" pitchFamily="34" charset="-120"/>
               </a:rPr>
-              <a:t>4. Deployment Portability (Docker):
+              <a:t>4. Device Responsiveness &amp; Survey Validation:
 </a:t>
             </a:r>
             <a:pPr indent="0" marL="0">
@@ -3344,7 +3345,7 @@
                 <a:ea typeface="Calibri" pitchFamily="34" charset="-122"/>
                 <a:cs typeface="Calibri" pitchFamily="34" charset="-120"/>
               </a:rPr>
-              <a:t>• Container Support: Can also run on local college servers or VPS using Docker.</a:t>
+              <a:t>• Verified form submissions and UI responsiveness across Google Chrome, Edge, and mobile screens.</a:t>
             </a:r>
             <a:endParaRPr lang="en-US" sz="1150" dirty="0"/>
           </a:p>
@@ -3476,7 +3477,7 @@
                 <a:ea typeface="Segoe UI" pitchFamily="34" charset="-122"/>
                 <a:cs typeface="Segoe UI" pitchFamily="34" charset="-120"/>
               </a:rPr>
-              <a:t>[INSERT DEPLOYMENT DIAGRAM]</a:t>
+              <a:t>[INSERT TEST CASES SUMMARY TABLE]</a:t>
             </a:r>
             <a:endParaRPr lang="en-US" sz="1400" dirty="0"/>
           </a:p>
@@ -3515,7 +3516,7 @@
                 <a:ea typeface="Calibri" pitchFamily="34" charset="-122"/>
                 <a:cs typeface="Calibri" pitchFamily="34" charset="-120"/>
               </a:rPr>
-              <a:t>Simple flow: Code on GitHub → Automatic Build → Live Website on Netlify &amp; Android Mobile App.</a:t>
+              <a:t>Table showing key test cases: User Authentication, Seat Capacity Limit, Q&amp;A Upvote Locking, and Survey Submission — All Passed (100%).</a:t>
             </a:r>
             <a:endParaRPr lang="en-US" sz="1100" dirty="0"/>
           </a:p>

</xml_diff>